<commit_message>
Add student names and roll numbers across PPT, PDF, script, and docs
- Gurtej Singh Lamba (2427030405)
- Abhiyansh Bhansali (2427030437)

Co-Authored-By: Claude Sonnet 4.6 <noreply@anthropic.com>
</commit_message>
<xml_diff>
--- a/presentation/AO_Star_Troubleshooting.pptx
+++ b/presentation/AO_Star_Troubleshooting.pptx
@@ -3414,27 +3414,27 @@
         <p:spPr>
           <a:xfrm>
             <a:off x="548640" y="4206240"/>
-            <a:ext cx="7315200" cy="457200"/>
-          </a:xfrm>
-          <a:prstGeom prst="rect">
-            <a:avLst/>
-          </a:prstGeom>
-          <a:noFill/>
-        </p:spPr>
-        <p:txBody>
-          <a:bodyPr wrap="square">
-            <a:spAutoFit/>
-          </a:bodyPr>
-          <a:lstStyle/>
-          <a:p>
-            <a:pPr algn="l"/>
-            <a:r>
-              <a:rPr sz="1800" b="1" i="0">
+            <a:ext cx="10972800" cy="457200"/>
+          </a:xfrm>
+          <a:prstGeom prst="rect">
+            <a:avLst/>
+          </a:prstGeom>
+          <a:noFill/>
+        </p:spPr>
+        <p:txBody>
+          <a:bodyPr wrap="square">
+            <a:spAutoFit/>
+          </a:bodyPr>
+          <a:lstStyle/>
+          <a:p>
+            <a:pPr algn="l"/>
+            <a:r>
+              <a:rPr sz="1700" b="1" i="0">
                 <a:solidFill>
                   <a:srgbClr val="FFFFFF"/>
                 </a:solidFill>
               </a:rPr>
-              <a:t>Member 1  &amp;  Member 2</a:t>
+              <a:t>Gurtej Singh Lamba  (2427030405)      Abhiyansh Bhansali  (2427030437)</a:t>
             </a:r>
           </a:p>
         </p:txBody>

</xml_diff>